<commit_message>
docs: actualizar manual tecnico (12 slides) al estado actual
- Estado y Alertas como modulos separados; arbol 3 niveles y worklist
- Busqueda avanzada multi-select y compartir SKU/VES con respaldo
- Jerarquia completa VES/129/40/121/92/122 y perfiles XLSX
- Acceso local simulado y CI/CD con tests (Node 22, Actions + artifact)
</commit_message>
<xml_diff>
--- a/scripts/StockPulse_Manual_Tecnico.pptx
+++ b/scripts/StockPulse_Manual_Tecnico.pptx
@@ -15,6 +15,8 @@
     <p:sldId id="263" r:id="rId14"/>
     <p:sldId id="264" r:id="rId15"/>
     <p:sldId id="265" r:id="rId16"/>
+    <p:sldId id="266" r:id="rId17"/>
+    <p:sldId id="267" r:id="rId18"/>
   </p:sldIdLst>
   <p:sldSz cx="12191695" cy="6858000" type="screen4x3"/>
   <p:notesSz cx="6858000" cy="9144000"/>
@@ -3536,6 +3538,916 @@
         </p:nvSpPr>
         <p:spPr>
           <a:xfrm>
+            <a:off x="0" y="0"/>
+            <a:ext cx="109728" cy="6858000"/>
+          </a:xfrm>
+          <a:prstGeom prst="rect">
+            <a:avLst/>
+          </a:prstGeom>
+          <a:solidFill>
+            <a:srgbClr val="00D084"/>
+          </a:solidFill>
+          <a:ln>
+            <a:noFill/>
+          </a:ln>
+        </p:spPr>
+        <p:style>
+          <a:lnRef idx="1">
+            <a:schemeClr val="accent1"/>
+          </a:lnRef>
+          <a:fillRef idx="3">
+            <a:schemeClr val="accent1"/>
+          </a:fillRef>
+          <a:effectRef idx="2">
+            <a:schemeClr val="accent1"/>
+          </a:effectRef>
+          <a:fontRef idx="minor">
+            <a:schemeClr val="lt1"/>
+          </a:fontRef>
+        </p:style>
+        <p:txBody>
+          <a:bodyPr rtlCol="0" anchor="ctr"/>
+          <a:lstStyle/>
+          <a:p>
+            <a:pPr algn="ctr"/>
+          </a:p>
+        </p:txBody>
+      </p:sp>
+      <p:sp>
+        <p:nvSpPr>
+          <p:cNvPr id="4" name="Oval 3"/>
+          <p:cNvSpPr/>
+          <p:nvPr/>
+        </p:nvSpPr>
+        <p:spPr>
+          <a:xfrm>
+            <a:off x="274320" y="274320"/>
+            <a:ext cx="548640" cy="548640"/>
+          </a:xfrm>
+          <a:prstGeom prst="ellipse">
+            <a:avLst/>
+          </a:prstGeom>
+          <a:solidFill>
+            <a:srgbClr val="00D084"/>
+          </a:solidFill>
+          <a:ln>
+            <a:noFill/>
+          </a:ln>
+        </p:spPr>
+        <p:style>
+          <a:lnRef idx="1">
+            <a:schemeClr val="accent1"/>
+          </a:lnRef>
+          <a:fillRef idx="3">
+            <a:schemeClr val="accent1"/>
+          </a:fillRef>
+          <a:effectRef idx="2">
+            <a:schemeClr val="accent1"/>
+          </a:effectRef>
+          <a:fontRef idx="minor">
+            <a:schemeClr val="lt1"/>
+          </a:fontRef>
+        </p:style>
+        <p:txBody>
+          <a:bodyPr rtlCol="0" anchor="ctr"/>
+          <a:lstStyle/>
+          <a:p>
+            <a:pPr algn="ctr"/>
+            <a:r>
+              <a:rPr sz="1800" b="1">
+                <a:solidFill>
+                  <a:srgbClr val="0F172A"/>
+                </a:solidFill>
+                <a:latin typeface="Segoe UI"/>
+              </a:rPr>
+              <a:t>08</a:t>
+            </a:r>
+          </a:p>
+        </p:txBody>
+      </p:sp>
+      <p:sp>
+        <p:nvSpPr>
+          <p:cNvPr id="5" name="TextBox 4"/>
+          <p:cNvSpPr txBox="1"/>
+          <p:nvPr/>
+        </p:nvSpPr>
+        <p:spPr>
+          <a:xfrm>
+            <a:off x="457200" y="274320"/>
+            <a:ext cx="11277295" cy="548640"/>
+          </a:xfrm>
+          <a:prstGeom prst="rect">
+            <a:avLst/>
+          </a:prstGeom>
+          <a:noFill/>
+        </p:spPr>
+        <p:txBody>
+          <a:bodyPr wrap="none">
+            <a:spAutoFit/>
+          </a:bodyPr>
+          <a:lstStyle/>
+          <a:p>
+            <a:r>
+              <a:rPr sz="2800" b="1">
+                <a:solidFill>
+                  <a:srgbClr val="F0F4F8"/>
+                </a:solidFill>
+                <a:latin typeface="Segoe UI"/>
+              </a:rPr>
+              <a:t>Despliegue y Operación</a:t>
+            </a:r>
+          </a:p>
+        </p:txBody>
+      </p:sp>
+      <p:sp>
+        <p:nvSpPr>
+          <p:cNvPr id="6" name="Rectangle 5"/>
+          <p:cNvSpPr/>
+          <p:nvPr/>
+        </p:nvSpPr>
+        <p:spPr>
+          <a:xfrm>
+            <a:off x="457200" y="822960"/>
+            <a:ext cx="1828800" cy="36576"/>
+          </a:xfrm>
+          <a:prstGeom prst="rect">
+            <a:avLst/>
+          </a:prstGeom>
+          <a:solidFill>
+            <a:srgbClr val="00D084"/>
+          </a:solidFill>
+          <a:ln>
+            <a:noFill/>
+          </a:ln>
+        </p:spPr>
+        <p:style>
+          <a:lnRef idx="1">
+            <a:schemeClr val="accent1"/>
+          </a:lnRef>
+          <a:fillRef idx="3">
+            <a:schemeClr val="accent1"/>
+          </a:fillRef>
+          <a:effectRef idx="2">
+            <a:schemeClr val="accent1"/>
+          </a:effectRef>
+          <a:fontRef idx="minor">
+            <a:schemeClr val="lt1"/>
+          </a:fontRef>
+        </p:style>
+        <p:txBody>
+          <a:bodyPr rtlCol="0" anchor="ctr"/>
+          <a:lstStyle/>
+          <a:p>
+            <a:pPr algn="ctr"/>
+          </a:p>
+        </p:txBody>
+      </p:sp>
+      <p:sp>
+        <p:nvSpPr>
+          <p:cNvPr id="7" name="Rounded Rectangle 6"/>
+          <p:cNvSpPr/>
+          <p:nvPr/>
+        </p:nvSpPr>
+        <p:spPr>
+          <a:xfrm>
+            <a:off x="457200" y="1097280"/>
+            <a:ext cx="11277295" cy="5303520"/>
+          </a:xfrm>
+          <a:prstGeom prst="roundRect">
+            <a:avLst/>
+          </a:prstGeom>
+          <a:solidFill>
+            <a:srgbClr val="1E293B"/>
+          </a:solidFill>
+          <a:ln w="12700">
+            <a:solidFill>
+              <a:srgbClr val="334155"/>
+            </a:solidFill>
+          </a:ln>
+        </p:spPr>
+        <p:style>
+          <a:lnRef idx="1">
+            <a:schemeClr val="accent1"/>
+          </a:lnRef>
+          <a:fillRef idx="3">
+            <a:schemeClr val="accent1"/>
+          </a:fillRef>
+          <a:effectRef idx="2">
+            <a:schemeClr val="accent1"/>
+          </a:effectRef>
+          <a:fontRef idx="minor">
+            <a:schemeClr val="lt1"/>
+          </a:fontRef>
+        </p:style>
+        <p:txBody>
+          <a:bodyPr rtlCol="0" anchor="ctr"/>
+          <a:lstStyle/>
+          <a:p>
+            <a:pPr algn="ctr"/>
+          </a:p>
+        </p:txBody>
+      </p:sp>
+      <p:sp>
+        <p:nvSpPr>
+          <p:cNvPr id="8" name="TextBox 7"/>
+          <p:cNvSpPr txBox="1"/>
+          <p:nvPr/>
+        </p:nvSpPr>
+        <p:spPr>
+          <a:xfrm>
+            <a:off x="640080" y="1280160"/>
+            <a:ext cx="10881360" cy="4937760"/>
+          </a:xfrm>
+          <a:prstGeom prst="rect">
+            <a:avLst/>
+          </a:prstGeom>
+          <a:noFill/>
+        </p:spPr>
+        <p:txBody>
+          <a:bodyPr wrap="square">
+            <a:spAutoFit/>
+          </a:bodyPr>
+          <a:lstStyle/>
+          <a:p>
+            <a:pPr>
+              <a:spcBef>
+                <a:spcPts val="1400"/>
+              </a:spcBef>
+            </a:pPr>
+            <a:r>
+              <a:rPr sz="1800" b="1">
+                <a:solidFill>
+                  <a:srgbClr val="00D084"/>
+                </a:solidFill>
+                <a:latin typeface="Segoe UI"/>
+              </a:rPr>
+              <a:t>▌ Infraestructura</a:t>
+            </a:r>
+          </a:p>
+          <a:p>
+            <a:pPr>
+              <a:spcBef>
+                <a:spcPts val="500"/>
+              </a:spcBef>
+            </a:pPr>
+            <a:r>
+              <a:rPr sz="1400" b="0">
+                <a:solidFill>
+                  <a:srgbClr val="F0F4F8"/>
+                </a:solidFill>
+                <a:latin typeface="Segoe UI"/>
+              </a:rPr>
+              <a:t>  ▸ Frontend: GitHub Pages (Actions + artifact, sin gh-pages)</a:t>
+            </a:r>
+          </a:p>
+          <a:p>
+            <a:pPr>
+              <a:spcBef>
+                <a:spcPts val="500"/>
+              </a:spcBef>
+            </a:pPr>
+            <a:r>
+              <a:rPr sz="1400" b="0">
+                <a:solidFill>
+                  <a:srgbClr val="F0F4F8"/>
+                </a:solidFill>
+                <a:latin typeface="Segoe UI"/>
+              </a:rPr>
+              <a:t>  ▸ Backend: Render (keep-alive cada 5 min)</a:t>
+            </a:r>
+          </a:p>
+          <a:p/>
+          <a:p>
+            <a:pPr>
+              <a:spcBef>
+                <a:spcPts val="1400"/>
+              </a:spcBef>
+            </a:pPr>
+            <a:r>
+              <a:rPr sz="1800" b="1">
+                <a:solidFill>
+                  <a:srgbClr val="00D084"/>
+                </a:solidFill>
+                <a:latin typeface="Segoe UI"/>
+              </a:rPr>
+              <a:t>▌ CI/CD</a:t>
+            </a:r>
+          </a:p>
+          <a:p>
+            <a:pPr>
+              <a:spcBef>
+                <a:spcPts val="500"/>
+              </a:spcBef>
+            </a:pPr>
+            <a:r>
+              <a:rPr sz="1400" b="0">
+                <a:solidFill>
+                  <a:srgbClr val="F0F4F8"/>
+                </a:solidFill>
+                <a:latin typeface="Segoe UI"/>
+              </a:rPr>
+              <a:t>  ▸ Push a main → npm ci → npm test → build → deploy</a:t>
+            </a:r>
+          </a:p>
+          <a:p>
+            <a:pPr>
+              <a:spcBef>
+                <a:spcPts val="500"/>
+              </a:spcBef>
+            </a:pPr>
+            <a:r>
+              <a:rPr sz="1400" b="0">
+                <a:solidFill>
+                  <a:srgbClr val="F0F4F8"/>
+                </a:solidFill>
+                <a:latin typeface="Segoe UI"/>
+              </a:rPr>
+              <a:t>  ▸ Node 22; paths-ignore para docs/scripts</a:t>
+            </a:r>
+          </a:p>
+          <a:p/>
+          <a:p>
+            <a:pPr>
+              <a:spcBef>
+                <a:spcPts val="1400"/>
+              </a:spcBef>
+            </a:pPr>
+            <a:r>
+              <a:rPr sz="1800" b="1">
+                <a:solidFill>
+                  <a:srgbClr val="00D084"/>
+                </a:solidFill>
+                <a:latin typeface="Segoe UI"/>
+              </a:rPr>
+              <a:t>▌ Ventana operativa</a:t>
+            </a:r>
+          </a:p>
+          <a:p>
+            <a:pPr>
+              <a:spcBef>
+                <a:spcPts val="500"/>
+              </a:spcBef>
+            </a:pPr>
+            <a:r>
+              <a:rPr sz="1400" b="0">
+                <a:solidFill>
+                  <a:srgbClr val="F0F4F8"/>
+                </a:solidFill>
+                <a:latin typeface="Segoe UI"/>
+              </a:rPr>
+              <a:t>  ▸ Lun-Sáb 07:00-22:59 Lima</a:t>
+            </a:r>
+          </a:p>
+          <a:p>
+            <a:pPr>
+              <a:spcBef>
+                <a:spcPts val="500"/>
+              </a:spcBef>
+            </a:pPr>
+            <a:r>
+              <a:rPr sz="1400" b="0">
+                <a:solidFill>
+                  <a:srgbClr val="F0F4F8"/>
+                </a:solidFill>
+                <a:latin typeface="Segoe UI"/>
+              </a:rPr>
+              <a:t>  ▸ Dom/madrugada: datos del último ciclo</a:t>
+            </a:r>
+          </a:p>
+        </p:txBody>
+      </p:sp>
+    </p:spTree>
+  </p:cSld>
+  <p:clrMapOvr>
+    <a:masterClrMapping/>
+  </p:clrMapOvr>
+</p:sld>
+</file>
+
+<file path=ppt/slides/slide11.xml><?xml version="1.0" encoding="utf-8"?>
+<p:sld xmlns:a="http://schemas.openxmlformats.org/drawingml/2006/main" xmlns:p="http://schemas.openxmlformats.org/presentationml/2006/main" xmlns:r="http://schemas.openxmlformats.org/officeDocument/2006/relationships">
+  <p:cSld>
+    <p:spTree>
+      <p:nvGrpSpPr>
+        <p:cNvPr id="1" name=""/>
+        <p:cNvGrpSpPr/>
+        <p:nvPr/>
+      </p:nvGrpSpPr>
+      <p:grpSpPr/>
+      <p:sp>
+        <p:nvSpPr>
+          <p:cNvPr id="2" name="Rectangle 1"/>
+          <p:cNvSpPr/>
+          <p:nvPr/>
+        </p:nvSpPr>
+        <p:spPr>
+          <a:xfrm>
+            <a:off x="0" y="0"/>
+            <a:ext cx="12191695" cy="6858000"/>
+          </a:xfrm>
+          <a:prstGeom prst="rect">
+            <a:avLst/>
+          </a:prstGeom>
+          <a:solidFill>
+            <a:srgbClr val="0F172A"/>
+          </a:solidFill>
+          <a:ln>
+            <a:noFill/>
+          </a:ln>
+        </p:spPr>
+        <p:style>
+          <a:lnRef idx="1">
+            <a:schemeClr val="accent1"/>
+          </a:lnRef>
+          <a:fillRef idx="3">
+            <a:schemeClr val="accent1"/>
+          </a:fillRef>
+          <a:effectRef idx="2">
+            <a:schemeClr val="accent1"/>
+          </a:effectRef>
+          <a:fontRef idx="minor">
+            <a:schemeClr val="lt1"/>
+          </a:fontRef>
+        </p:style>
+        <p:txBody>
+          <a:bodyPr rtlCol="0" anchor="ctr"/>
+          <a:lstStyle/>
+          <a:p>
+            <a:pPr algn="ctr"/>
+          </a:p>
+        </p:txBody>
+      </p:sp>
+      <p:sp>
+        <p:nvSpPr>
+          <p:cNvPr id="3" name="Rectangle 2"/>
+          <p:cNvSpPr/>
+          <p:nvPr/>
+        </p:nvSpPr>
+        <p:spPr>
+          <a:xfrm>
+            <a:off x="0" y="0"/>
+            <a:ext cx="109728" cy="6858000"/>
+          </a:xfrm>
+          <a:prstGeom prst="rect">
+            <a:avLst/>
+          </a:prstGeom>
+          <a:solidFill>
+            <a:srgbClr val="00D084"/>
+          </a:solidFill>
+          <a:ln>
+            <a:noFill/>
+          </a:ln>
+        </p:spPr>
+        <p:style>
+          <a:lnRef idx="1">
+            <a:schemeClr val="accent1"/>
+          </a:lnRef>
+          <a:fillRef idx="3">
+            <a:schemeClr val="accent1"/>
+          </a:fillRef>
+          <a:effectRef idx="2">
+            <a:schemeClr val="accent1"/>
+          </a:effectRef>
+          <a:fontRef idx="minor">
+            <a:schemeClr val="lt1"/>
+          </a:fontRef>
+        </p:style>
+        <p:txBody>
+          <a:bodyPr rtlCol="0" anchor="ctr"/>
+          <a:lstStyle/>
+          <a:p>
+            <a:pPr algn="ctr"/>
+          </a:p>
+        </p:txBody>
+      </p:sp>
+      <p:sp>
+        <p:nvSpPr>
+          <p:cNvPr id="4" name="Oval 3"/>
+          <p:cNvSpPr/>
+          <p:nvPr/>
+        </p:nvSpPr>
+        <p:spPr>
+          <a:xfrm>
+            <a:off x="274320" y="274320"/>
+            <a:ext cx="548640" cy="548640"/>
+          </a:xfrm>
+          <a:prstGeom prst="ellipse">
+            <a:avLst/>
+          </a:prstGeom>
+          <a:solidFill>
+            <a:srgbClr val="00D084"/>
+          </a:solidFill>
+          <a:ln>
+            <a:noFill/>
+          </a:ln>
+        </p:spPr>
+        <p:style>
+          <a:lnRef idx="1">
+            <a:schemeClr val="accent1"/>
+          </a:lnRef>
+          <a:fillRef idx="3">
+            <a:schemeClr val="accent1"/>
+          </a:fillRef>
+          <a:effectRef idx="2">
+            <a:schemeClr val="accent1"/>
+          </a:effectRef>
+          <a:fontRef idx="minor">
+            <a:schemeClr val="lt1"/>
+          </a:fontRef>
+        </p:style>
+        <p:txBody>
+          <a:bodyPr rtlCol="0" anchor="ctr"/>
+          <a:lstStyle/>
+          <a:p>
+            <a:pPr algn="ctr"/>
+            <a:r>
+              <a:rPr sz="1800" b="1">
+                <a:solidFill>
+                  <a:srgbClr val="0F172A"/>
+                </a:solidFill>
+                <a:latin typeface="Segoe UI"/>
+              </a:rPr>
+              <a:t>09</a:t>
+            </a:r>
+          </a:p>
+        </p:txBody>
+      </p:sp>
+      <p:sp>
+        <p:nvSpPr>
+          <p:cNvPr id="5" name="TextBox 4"/>
+          <p:cNvSpPr txBox="1"/>
+          <p:nvPr/>
+        </p:nvSpPr>
+        <p:spPr>
+          <a:xfrm>
+            <a:off x="457200" y="274320"/>
+            <a:ext cx="11277295" cy="548640"/>
+          </a:xfrm>
+          <a:prstGeom prst="rect">
+            <a:avLst/>
+          </a:prstGeom>
+          <a:noFill/>
+        </p:spPr>
+        <p:txBody>
+          <a:bodyPr wrap="none">
+            <a:spAutoFit/>
+          </a:bodyPr>
+          <a:lstStyle/>
+          <a:p>
+            <a:r>
+              <a:rPr sz="2800" b="1">
+                <a:solidFill>
+                  <a:srgbClr val="F0F4F8"/>
+                </a:solidFill>
+                <a:latin typeface="Segoe UI"/>
+              </a:rPr>
+              <a:t>Troubleshooting Común</a:t>
+            </a:r>
+          </a:p>
+        </p:txBody>
+      </p:sp>
+      <p:sp>
+        <p:nvSpPr>
+          <p:cNvPr id="6" name="Rectangle 5"/>
+          <p:cNvSpPr/>
+          <p:nvPr/>
+        </p:nvSpPr>
+        <p:spPr>
+          <a:xfrm>
+            <a:off x="457200" y="822960"/>
+            <a:ext cx="1828800" cy="36576"/>
+          </a:xfrm>
+          <a:prstGeom prst="rect">
+            <a:avLst/>
+          </a:prstGeom>
+          <a:solidFill>
+            <a:srgbClr val="00D084"/>
+          </a:solidFill>
+          <a:ln>
+            <a:noFill/>
+          </a:ln>
+        </p:spPr>
+        <p:style>
+          <a:lnRef idx="1">
+            <a:schemeClr val="accent1"/>
+          </a:lnRef>
+          <a:fillRef idx="3">
+            <a:schemeClr val="accent1"/>
+          </a:fillRef>
+          <a:effectRef idx="2">
+            <a:schemeClr val="accent1"/>
+          </a:effectRef>
+          <a:fontRef idx="minor">
+            <a:schemeClr val="lt1"/>
+          </a:fontRef>
+        </p:style>
+        <p:txBody>
+          <a:bodyPr rtlCol="0" anchor="ctr"/>
+          <a:lstStyle/>
+          <a:p>
+            <a:pPr algn="ctr"/>
+          </a:p>
+        </p:txBody>
+      </p:sp>
+      <p:sp>
+        <p:nvSpPr>
+          <p:cNvPr id="7" name="Rounded Rectangle 6"/>
+          <p:cNvSpPr/>
+          <p:nvPr/>
+        </p:nvSpPr>
+        <p:spPr>
+          <a:xfrm>
+            <a:off x="457200" y="1097280"/>
+            <a:ext cx="11277295" cy="5303520"/>
+          </a:xfrm>
+          <a:prstGeom prst="roundRect">
+            <a:avLst/>
+          </a:prstGeom>
+          <a:solidFill>
+            <a:srgbClr val="1E293B"/>
+          </a:solidFill>
+          <a:ln w="12700">
+            <a:solidFill>
+              <a:srgbClr val="334155"/>
+            </a:solidFill>
+          </a:ln>
+        </p:spPr>
+        <p:style>
+          <a:lnRef idx="1">
+            <a:schemeClr val="accent1"/>
+          </a:lnRef>
+          <a:fillRef idx="3">
+            <a:schemeClr val="accent1"/>
+          </a:fillRef>
+          <a:effectRef idx="2">
+            <a:schemeClr val="accent1"/>
+          </a:effectRef>
+          <a:fontRef idx="minor">
+            <a:schemeClr val="lt1"/>
+          </a:fontRef>
+        </p:style>
+        <p:txBody>
+          <a:bodyPr rtlCol="0" anchor="ctr"/>
+          <a:lstStyle/>
+          <a:p>
+            <a:pPr algn="ctr"/>
+          </a:p>
+        </p:txBody>
+      </p:sp>
+      <p:sp>
+        <p:nvSpPr>
+          <p:cNvPr id="8" name="TextBox 7"/>
+          <p:cNvSpPr txBox="1"/>
+          <p:nvPr/>
+        </p:nvSpPr>
+        <p:spPr>
+          <a:xfrm>
+            <a:off x="640080" y="1280160"/>
+            <a:ext cx="10881360" cy="4937760"/>
+          </a:xfrm>
+          <a:prstGeom prst="rect">
+            <a:avLst/>
+          </a:prstGeom>
+          <a:noFill/>
+        </p:spPr>
+        <p:txBody>
+          <a:bodyPr wrap="square">
+            <a:spAutoFit/>
+          </a:bodyPr>
+          <a:lstStyle/>
+          <a:p>
+            <a:pPr>
+              <a:spcBef>
+                <a:spcPts val="1400"/>
+              </a:spcBef>
+            </a:pPr>
+            <a:r>
+              <a:rPr sz="1800" b="1">
+                <a:solidFill>
+                  <a:srgbClr val="00D084"/>
+                </a:solidFill>
+                <a:latin typeface="Segoe UI"/>
+              </a:rPr>
+              <a:t>▌ Cache stale</a:t>
+            </a:r>
+          </a:p>
+          <a:p>
+            <a:pPr>
+              <a:spcBef>
+                <a:spcPts val="500"/>
+              </a:spcBef>
+            </a:pPr>
+            <a:r>
+              <a:rPr sz="1400" b="0">
+                <a:solidFill>
+                  <a:srgbClr val="F0F4F8"/>
+                </a:solidFill>
+                <a:latin typeface="Segoe UI"/>
+              </a:rPr>
+              <a:t>  ▸ Síntoma: datos no se actualizan</a:t>
+            </a:r>
+          </a:p>
+          <a:p>
+            <a:pPr>
+              <a:spcBef>
+                <a:spcPts val="500"/>
+              </a:spcBef>
+            </a:pPr>
+            <a:r>
+              <a:rPr sz="1400" b="0">
+                <a:solidFill>
+                  <a:srgbClr val="F0F4F8"/>
+                </a:solidFill>
+                <a:latin typeface="Segoe UI"/>
+              </a:rPr>
+              <a:t>  ▸ Solución: refresh o limpiar localStorage</a:t>
+            </a:r>
+          </a:p>
+          <a:p/>
+          <a:p>
+            <a:pPr>
+              <a:spcBef>
+                <a:spcPts val="1400"/>
+              </a:spcBef>
+            </a:pPr>
+            <a:r>
+              <a:rPr sz="1800" b="1">
+                <a:solidFill>
+                  <a:srgbClr val="00D084"/>
+                </a:solidFill>
+                <a:latin typeface="Segoe UI"/>
+              </a:rPr>
+              <a:t>▌ Categoría OTROS</a:t>
+            </a:r>
+          </a:p>
+          <a:p>
+            <a:pPr>
+              <a:spcBef>
+                <a:spcPts val="500"/>
+              </a:spcBef>
+            </a:pPr>
+            <a:r>
+              <a:rPr sz="1400" b="0">
+                <a:solidFill>
+                  <a:srgbClr val="F0F4F8"/>
+                </a:solidFill>
+                <a:latin typeface="Segoe UI"/>
+              </a:rPr>
+              <a:t>  ▸ Causa: código de línea no mapeado</a:t>
+            </a:r>
+          </a:p>
+          <a:p>
+            <a:pPr>
+              <a:spcBef>
+                <a:spcPts val="500"/>
+              </a:spcBef>
+            </a:pPr>
+            <a:r>
+              <a:rPr sz="1400" b="0">
+                <a:solidFill>
+                  <a:srgbClr val="F0F4F8"/>
+                </a:solidFill>
+                <a:latin typeface="Segoe UI"/>
+              </a:rPr>
+              <a:t>  ▸ Solución: agregar a CATEGORIAS en constants.py</a:t>
+            </a:r>
+          </a:p>
+          <a:p/>
+          <a:p>
+            <a:pPr>
+              <a:spcBef>
+                <a:spcPts val="1400"/>
+              </a:spcBef>
+            </a:pPr>
+            <a:r>
+              <a:rPr sz="1800" b="1">
+                <a:solidFill>
+                  <a:srgbClr val="00D084"/>
+                </a:solidFill>
+                <a:latin typeface="Segoe UI"/>
+              </a:rPr>
+              <a:t>▌ Disponible 0 con existencias</a:t>
+            </a:r>
+          </a:p>
+          <a:p>
+            <a:pPr>
+              <a:spcBef>
+                <a:spcPts val="500"/>
+              </a:spcBef>
+            </a:pPr>
+            <a:r>
+              <a:rPr sz="1400" b="0">
+                <a:solidFill>
+                  <a:srgbClr val="F0F4F8"/>
+                </a:solidFill>
+                <a:latin typeface="Segoe UI"/>
+              </a:rPr>
+              <a:t>  ▸ Causa: stock solo en lotes no-VES (129/40/121/92/122 o mktd)</a:t>
+            </a:r>
+          </a:p>
+          <a:p>
+            <a:pPr>
+              <a:spcBef>
+                <a:spcPts val="500"/>
+              </a:spcBef>
+            </a:pPr>
+            <a:r>
+              <a:rPr sz="1400" b="0">
+                <a:solidFill>
+                  <a:srgbClr val="F0F4F8"/>
+                </a:solidFill>
+                <a:latin typeface="Segoe UI"/>
+              </a:rPr>
+              <a:t>  ▸ Solución: revisar chips por almacén o columnas del XLSX</a:t>
+            </a:r>
+          </a:p>
+          <a:p>
+            <a:pPr>
+              <a:spcBef>
+                <a:spcPts val="500"/>
+              </a:spcBef>
+            </a:pPr>
+            <a:r>
+              <a:rPr sz="1400" b="0">
+                <a:solidFill>
+                  <a:srgbClr val="F0F4F8"/>
+                </a:solidFill>
+                <a:latin typeface="Segoe UI"/>
+              </a:rPr>
+              <a:t>  ▸ 92 es informativo: no es disponible de venta</a:t>
+            </a:r>
+          </a:p>
+        </p:txBody>
+      </p:sp>
+    </p:spTree>
+  </p:cSld>
+  <p:clrMapOvr>
+    <a:masterClrMapping/>
+  </p:clrMapOvr>
+</p:sld>
+</file>
+
+<file path=ppt/slides/slide12.xml><?xml version="1.0" encoding="utf-8"?>
+<p:sld xmlns:a="http://schemas.openxmlformats.org/drawingml/2006/main" xmlns:p="http://schemas.openxmlformats.org/presentationml/2006/main" xmlns:r="http://schemas.openxmlformats.org/officeDocument/2006/relationships">
+  <p:cSld>
+    <p:spTree>
+      <p:nvGrpSpPr>
+        <p:cNvPr id="1" name=""/>
+        <p:cNvGrpSpPr/>
+        <p:nvPr/>
+      </p:nvGrpSpPr>
+      <p:grpSpPr/>
+      <p:sp>
+        <p:nvSpPr>
+          <p:cNvPr id="2" name="Rectangle 1"/>
+          <p:cNvSpPr/>
+          <p:nvPr/>
+        </p:nvSpPr>
+        <p:spPr>
+          <a:xfrm>
+            <a:off x="0" y="0"/>
+            <a:ext cx="12191695" cy="6858000"/>
+          </a:xfrm>
+          <a:prstGeom prst="rect">
+            <a:avLst/>
+          </a:prstGeom>
+          <a:solidFill>
+            <a:srgbClr val="0F172A"/>
+          </a:solidFill>
+          <a:ln>
+            <a:noFill/>
+          </a:ln>
+        </p:spPr>
+        <p:style>
+          <a:lnRef idx="1">
+            <a:schemeClr val="accent1"/>
+          </a:lnRef>
+          <a:fillRef idx="3">
+            <a:schemeClr val="accent1"/>
+          </a:fillRef>
+          <a:effectRef idx="2">
+            <a:schemeClr val="accent1"/>
+          </a:effectRef>
+          <a:fontRef idx="minor">
+            <a:schemeClr val="lt1"/>
+          </a:fontRef>
+        </p:style>
+        <p:txBody>
+          <a:bodyPr rtlCol="0" anchor="ctr"/>
+          <a:lstStyle/>
+          <a:p>
+            <a:pPr algn="ctr"/>
+          </a:p>
+        </p:txBody>
+      </p:sp>
+      <p:sp>
+        <p:nvSpPr>
+          <p:cNvPr id="3" name="Rectangle 2"/>
+          <p:cNvSpPr/>
+          <p:nvPr/>
+        </p:nvSpPr>
+        <p:spPr>
+          <a:xfrm>
             <a:off x="4270248" y="2743200"/>
             <a:ext cx="3657600" cy="54864"/>
           </a:xfrm>
@@ -4125,7 +5037,7 @@
                 </a:solidFill>
                 <a:latin typeface="Segoe UI"/>
               </a:rPr>
-              <a:t>  ▸ Lit 3 Web Components, deploy en GitHub Pages</a:t>
+              <a:t>  ▸ Lit 3 + Vite 8, deploy en GitHub Pages (Actions + artifact)</a:t>
             </a:r>
           </a:p>
           <a:p>
@@ -4141,9 +5053,41 @@
                 </a:solidFill>
                 <a:latin typeface="Segoe UI"/>
               </a:rPr>
+              <a:t>  ▸ Instalable en móvil (banner nativo / instrucciones iOS)</a:t>
+            </a:r>
+          </a:p>
+          <a:p>
+            <a:pPr>
+              <a:spcBef>
+                <a:spcPts val="500"/>
+              </a:spcBef>
+            </a:pPr>
+            <a:r>
+              <a:rPr sz="1400" b="0">
+                <a:solidFill>
+                  <a:srgbClr val="F0F4F8"/>
+                </a:solidFill>
+                <a:latin typeface="Segoe UI"/>
+              </a:rPr>
               <a:t>  ▸ Cache 3 capas: memoria → sessionStorage → localStorage</a:t>
             </a:r>
           </a:p>
+          <a:p>
+            <a:pPr>
+              <a:spcBef>
+                <a:spcPts val="500"/>
+              </a:spcBef>
+            </a:pPr>
+            <a:r>
+              <a:rPr sz="1400" b="0">
+                <a:solidFill>
+                  <a:srgbClr val="F0F4F8"/>
+                </a:solidFill>
+                <a:latin typeface="Segoe UI"/>
+              </a:rPr>
+              <a:t>  ▸ Sesión local simulada (nombre + @cipsa.com.pe)</a:t>
+            </a:r>
+          </a:p>
           <a:p/>
           <a:p>
             <a:pPr>
@@ -4190,7 +5134,7 @@
                 </a:solidFill>
                 <a:latin typeface="Segoe UI"/>
               </a:rPr>
-              <a:t>  ▸ Enriquecimiento automático con catálogo maestro</a:t>
+              <a:t>  ▸ Modelo enriquecido: stock, flags comerciales y revisión</a:t>
             </a:r>
           </a:p>
           <a:p>
@@ -4255,7 +5199,7 @@
                 </a:solidFill>
                 <a:latin typeface="Segoe UI"/>
               </a:rPr>
-              <a:t>  ▸ Campos: SKU, descripción, un_bx, peso, líneas</a:t>
+              <a:t>  ▸ SKU, descripción, un_bx, peso, líneas y nombres de almacén</a:t>
             </a:r>
           </a:p>
         </p:txBody>
@@ -5142,7 +6086,7 @@
                 </a:solidFill>
                 <a:latin typeface="Segoe UI"/>
               </a:rPr>
-              <a:t>Funcionalidades Principales</a:t>
+              <a:t>Estado y Alertas</a:t>
             </a:r>
           </a:p>
         </p:txBody>
@@ -5269,7 +6213,7 @@
                 </a:solidFill>
                 <a:latin typeface="Segoe UI"/>
               </a:rPr>
-              <a:t>▌ Dashboard y Estado</a:t>
+              <a:t>▌ Estado (exploración)</a:t>
             </a:r>
           </a:p>
           <a:p>
@@ -5285,7 +6229,7 @@
                 </a:solidFill>
                 <a:latin typeface="Segoe UI"/>
               </a:rPr>
-              <a:t>  ▸ KPIs y lista expandible por categoría (estados sobre VES)</a:t>
+              <a:t>  ▸ KPIs sobre Disponible VES (catálogo vigente)</a:t>
             </a:r>
           </a:p>
           <a:p>
@@ -5301,7 +6245,23 @@
                 </a:solidFill>
                 <a:latin typeface="Segoe UI"/>
               </a:rPr>
-              <a:t>  ▸ Buscador interno con auto-expand de coincidencias</a:t>
+              <a:t>  ▸ Árbol categoría → línea → SKU (solo lectura)</a:t>
+            </a:r>
+          </a:p>
+          <a:p>
+            <a:pPr>
+              <a:spcBef>
+                <a:spcPts val="500"/>
+              </a:spcBef>
+            </a:pPr>
+            <a:r>
+              <a:rPr sz="1400" b="0">
+                <a:solidFill>
+                  <a:srgbClr val="F0F4F8"/>
+                </a:solidFill>
+                <a:latin typeface="Segoe UI"/>
+              </a:rPr>
+              <a:t>  ▸ 'Generar reporte' abre Pulso con la selección</a:t>
             </a:r>
           </a:p>
           <a:p/>
@@ -5318,7 +6278,7 @@
                 </a:solidFill>
                 <a:latin typeface="Segoe UI"/>
               </a:rPr>
-              <a:t>▌ Búsqueda Avanzada</a:t>
+              <a:t>▌ Alertas (worklist)</a:t>
             </a:r>
           </a:p>
           <a:p>
@@ -5334,7 +6294,7 @@
                 </a:solidFill>
                 <a:latin typeface="Segoe UI"/>
               </a:rPr>
-              <a:t>  ▸ Multi-término AND sin tildes + voz + link ?q=SKU</a:t>
+              <a:t>  ▸ Módulo separado: solo 0 y bajo stock</a:t>
             </a:r>
           </a:p>
           <a:p>
@@ -5350,7 +6310,23 @@
                 </a:solidFill>
                 <a:latin typeface="Segoe UI"/>
               </a:rPr>
-              <a:t>  ▸ SKU, EAN, línea, categoría, keywords</a:t>
+              <a:t>  ▸ Mismo universo: catálogo vigente</a:t>
+            </a:r>
+          </a:p>
+          <a:p>
+            <a:pPr>
+              <a:spcBef>
+                <a:spcPts val="500"/>
+              </a:spcBef>
+            </a:pPr>
+            <a:r>
+              <a:rPr sz="1400" b="0">
+                <a:solidFill>
+                  <a:srgbClr val="F0F4F8"/>
+                </a:solidFill>
+                <a:latin typeface="Segoe UI"/>
+              </a:rPr>
+              <a:t>  ▸ Conteos y exportación (Todos/Bajo/Sin)</a:t>
             </a:r>
           </a:p>
           <a:p/>
@@ -5367,7 +6343,7 @@
                 </a:solidFill>
                 <a:latin typeface="Segoe UI"/>
               </a:rPr>
-              <a:t>▌ Jerarquía de Almacenes (lotes no se suman)</a:t>
+              <a:t>▌ Código compartido</a:t>
             </a:r>
           </a:p>
           <a:p>
@@ -5383,88 +6359,7 @@
                 </a:solidFill>
                 <a:latin typeface="Segoe UI"/>
               </a:rPr>
-              <a:t>  ▸ VES venta · 129 secundario · 40 traslado (≥10 bx)</a:t>
-            </a:r>
-          </a:p>
-          <a:p>
-            <a:pPr>
-              <a:spcBef>
-                <a:spcPts val="500"/>
-              </a:spcBef>
-            </a:pPr>
-            <a:r>
-              <a:rPr sz="1400" b="0">
-                <a:solidFill>
-                  <a:srgbClr val="F0F4F8"/>
-                </a:solidFill>
-                <a:latin typeface="Segoe UI"/>
-              </a:rPr>
-              <a:t>  ▸ 121 inspección/QC · 122 exportación (informativo)</a:t>
-            </a:r>
-          </a:p>
-          <a:p>
-            <a:pPr>
-              <a:spcBef>
-                <a:spcPts val="500"/>
-              </a:spcBef>
-            </a:pPr>
-            <a:r>
-              <a:rPr sz="1400" b="0">
-                <a:solidFill>
-                  <a:srgbClr val="F0F4F8"/>
-                </a:solidFill>
-                <a:latin typeface="Segoe UI"/>
-              </a:rPr>
-              <a:t>  ▸ Badges + leyenda de colores por lote</a:t>
-            </a:r>
-          </a:p>
-          <a:p/>
-          <a:p>
-            <a:pPr>
-              <a:spcBef>
-                <a:spcPts val="1400"/>
-              </a:spcBef>
-            </a:pPr>
-            <a:r>
-              <a:rPr sz="1800" b="1">
-                <a:solidFill>
-                  <a:srgbClr val="00D084"/>
-                </a:solidFill>
-                <a:latin typeface="Segoe UI"/>
-              </a:rPr>
-              <a:t>▌ Reportes XLSX</a:t>
-            </a:r>
-          </a:p>
-          <a:p>
-            <a:pPr>
-              <a:spcBef>
-                <a:spcPts val="500"/>
-              </a:spcBef>
-            </a:pPr>
-            <a:r>
-              <a:rPr sz="1400" b="0">
-                <a:solidFill>
-                  <a:srgbClr val="F0F4F8"/>
-                </a:solidFill>
-                <a:latin typeface="Segoe UI"/>
-              </a:rPr>
-              <a:t>  ▸ 'Disponible VES'; columnas 129/40/121 + hoja 122</a:t>
-            </a:r>
-          </a:p>
-          <a:p>
-            <a:pPr>
-              <a:spcBef>
-                <a:spcPts val="500"/>
-              </a:spcBef>
-            </a:pPr>
-            <a:r>
-              <a:rPr sz="1400" b="0">
-                <a:solidFill>
-                  <a:srgbClr val="F0F4F8"/>
-                </a:solidFill>
-                <a:latin typeface="Segoe UI"/>
-              </a:rPr>
-              <a:t>  ▸ Descarga directa 122; solicitante recordado en equipo</a:t>
+              <a:t>  ▸ Fila/detalle de SKU y chips de almacén reutilizados</a:t>
             </a:r>
           </a:p>
         </p:txBody>
@@ -5654,7 +6549,7 @@
                 </a:solidFill>
                 <a:latin typeface="Segoe UI"/>
               </a:rPr>
-              <a:t>Sistema de Alertas</a:t>
+              <a:t>Búsqueda y Compartir</a:t>
             </a:r>
           </a:p>
         </p:txBody>
@@ -5781,7 +6676,7 @@
                 </a:solidFill>
                 <a:latin typeface="Segoe UI"/>
               </a:rPr>
-              <a:t>▌ Tipos de Alerta</a:t>
+              <a:t>▌ Búsqueda</a:t>
             </a:r>
           </a:p>
           <a:p>
@@ -5797,7 +6692,7 @@
                 </a:solidFill>
                 <a:latin typeface="Segoe UI"/>
               </a:rPr>
-              <a:t>  ▸ Crítico (rojo): SKU agotado (bx = 0)</a:t>
+              <a:t>  ▸ Multi-término AND sin tildes + voz</a:t>
             </a:r>
           </a:p>
           <a:p>
@@ -5813,7 +6708,23 @@
                 </a:solidFill>
                 <a:latin typeface="Segoe UI"/>
               </a:rPr>
-              <a:t>  ▸ Advertencia (amarillo): Stock bajo (1-9 cajas)</a:t>
+              <a:t>  ▸ Exact por SKU/EAN (con o sin ceros)</a:t>
+            </a:r>
+          </a:p>
+          <a:p>
+            <a:pPr>
+              <a:spcBef>
+                <a:spcPts val="500"/>
+              </a:spcBef>
+            </a:pPr>
+            <a:r>
+              <a:rPr sz="1400" b="0">
+                <a:solidFill>
+                  <a:srgbClr val="F0F4F8"/>
+                </a:solidFill>
+                <a:latin typeface="Segoe UI"/>
+              </a:rPr>
+              <a:t>  ▸ Avanzada: Grupo, Tipo, Familia, Licencia, Categoría, Línea, Stock y Vigencia (multi-select)</a:t>
             </a:r>
           </a:p>
           <a:p/>
@@ -5830,7 +6741,7 @@
                 </a:solidFill>
                 <a:latin typeface="Segoe UI"/>
               </a:rPr>
-              <a:t>▌ Criterios</a:t>
+              <a:t>▌ Compartir</a:t>
             </a:r>
           </a:p>
           <a:p>
@@ -5846,7 +6757,7 @@
                 </a:solidFill>
                 <a:latin typeface="Segoe UI"/>
               </a:rPr>
-              <a:t>  ▸ Solo SKUs con estado_linea definido (catálogo)</a:t>
+              <a:t>  ▸ Multiselección de SKUs en el buscador</a:t>
             </a:r>
           </a:p>
           <a:p>
@@ -5862,24 +6773,7 @@
                 </a:solidFill>
                 <a:latin typeface="Segoe UI"/>
               </a:rPr>
-              <a:t>  ▸ Ordenados por prioridad y cantidad de cajas</a:t>
-            </a:r>
-          </a:p>
-          <a:p/>
-          <a:p>
-            <a:pPr>
-              <a:spcBef>
-                <a:spcPts val="1400"/>
-              </a:spcBef>
-            </a:pPr>
-            <a:r>
-              <a:rPr sz="1800" b="1">
-                <a:solidFill>
-                  <a:srgbClr val="00D084"/>
-                </a:solidFill>
-                <a:latin typeface="Segoe UI"/>
-              </a:rPr>
-              <a:t>▌ Visualización</a:t>
+              <a:t>  ▸ Mensaje breve: SKU, descripción, línea y VES</a:t>
             </a:r>
           </a:p>
           <a:p>
@@ -5895,7 +6789,7 @@
                 </a:solidFill>
                 <a:latin typeface="Segoe UI"/>
               </a:rPr>
-              <a:t>  ▸ Badge con contador en navegación</a:t>
+              <a:t>  ▸ Si VES = 0: respaldo 129 → 121 → 92</a:t>
             </a:r>
           </a:p>
           <a:p>
@@ -5911,7 +6805,7 @@
                 </a:solidFill>
                 <a:latin typeface="Segoe UI"/>
               </a:rPr>
-              <a:t>  ▸ Panel dedicado con filtros por tipo</a:t>
+              <a:t>  ▸ Envío por Web Share/WhatsApp o portapapeles</a:t>
             </a:r>
           </a:p>
         </p:txBody>
@@ -6101,7 +6995,7 @@
                 </a:solidFill>
                 <a:latin typeface="Segoe UI"/>
               </a:rPr>
-              <a:t>Seguridad y Acceso</a:t>
+              <a:t>Jerarquía de Almacenes</a:t>
             </a:r>
           </a:p>
         </p:txBody>
@@ -6228,7 +7122,7 @@
                 </a:solidFill>
                 <a:latin typeface="Segoe UI"/>
               </a:rPr>
-              <a:t>▌ Modelo de Autenticación</a:t>
+              <a:t>▌ Niveles</a:t>
             </a:r>
           </a:p>
           <a:p>
@@ -6244,7 +7138,7 @@
                 </a:solidFill>
                 <a:latin typeface="Segoe UI"/>
               </a:rPr>
-              <a:t>  ▸ S1_API_KEY: Administrativa (upload, catálogo)</a:t>
+              <a:t>  ▸ VES → venta directa (Disponible principal)</a:t>
             </a:r>
           </a:p>
           <a:p>
@@ -6260,7 +7154,71 @@
                 </a:solidFill>
                 <a:latin typeface="Segoe UI"/>
               </a:rPr>
-              <a:t>  ▸ S1_READ_API_KEY: Lectura para frontend</a:t>
+              <a:t>  ▸ 129 → secundario de venta (si VES = 0)</a:t>
+            </a:r>
+          </a:p>
+          <a:p>
+            <a:pPr>
+              <a:spcBef>
+                <a:spcPts val="500"/>
+              </a:spcBef>
+            </a:pPr>
+            <a:r>
+              <a:rPr sz="1400" b="0">
+                <a:solidFill>
+                  <a:srgbClr val="F0F4F8"/>
+                </a:solidFill>
+                <a:latin typeface="Segoe UI"/>
+              </a:rPr>
+              <a:t>  ▸ 40 → traslado (solo cantidad alta, ≥10 bx)</a:t>
+            </a:r>
+          </a:p>
+          <a:p>
+            <a:pPr>
+              <a:spcBef>
+                <a:spcPts val="500"/>
+              </a:spcBef>
+            </a:pPr>
+            <a:r>
+              <a:rPr sz="1400" b="0">
+                <a:solidFill>
+                  <a:srgbClr val="F0F4F8"/>
+                </a:solidFill>
+                <a:latin typeface="Segoe UI"/>
+              </a:rPr>
+              <a:t>  ▸ 121 → inspección principal (QC, lote por pasar a VES)</a:t>
+            </a:r>
+          </a:p>
+          <a:p>
+            <a:pPr>
+              <a:spcBef>
+                <a:spcPts val="500"/>
+              </a:spcBef>
+            </a:pPr>
+            <a:r>
+              <a:rPr sz="1400" b="0">
+                <a:solidFill>
+                  <a:srgbClr val="F0F4F8"/>
+                </a:solidFill>
+                <a:latin typeface="Segoe UI"/>
+              </a:rPr>
+              <a:t>  ▸ 92 → inspección secundaria (informativo)</a:t>
+            </a:r>
+          </a:p>
+          <a:p>
+            <a:pPr>
+              <a:spcBef>
+                <a:spcPts val="500"/>
+              </a:spcBef>
+            </a:pPr>
+            <a:r>
+              <a:rPr sz="1400" b="0">
+                <a:solidFill>
+                  <a:srgbClr val="F0F4F8"/>
+                </a:solidFill>
+                <a:latin typeface="Segoe UI"/>
+              </a:rPr>
+              <a:t>  ▸ 122 → exportación (informativo)</a:t>
             </a:r>
           </a:p>
           <a:p/>
@@ -6277,7 +7235,7 @@
                 </a:solidFill>
                 <a:latin typeface="Segoe UI"/>
               </a:rPr>
-              <a:t>▌ Endpoints Protegidos</a:t>
+              <a:t>▌ Reglas</a:t>
             </a:r>
           </a:p>
           <a:p>
@@ -6293,7 +7251,7 @@
                 </a:solidFill>
                 <a:latin typeface="Segoe UI"/>
               </a:rPr>
-              <a:t>  ▸ GET /stock, /health → requiere READ_KEY</a:t>
+              <a:t>  ▸ Los lotes NO se suman al Disponible VES</a:t>
             </a:r>
           </a:p>
           <a:p>
@@ -6309,24 +7267,7 @@
                 </a:solidFill>
                 <a:latin typeface="Segoe UI"/>
               </a:rPr>
-              <a:t>  ▸ POST /catalog/upload → requiere ADMIN_KEY</a:t>
-            </a:r>
-          </a:p>
-          <a:p/>
-          <a:p>
-            <a:pPr>
-              <a:spcBef>
-                <a:spcPts val="1400"/>
-              </a:spcBef>
-            </a:pPr>
-            <a:r>
-              <a:rPr sz="1800" b="1">
-                <a:solidFill>
-                  <a:srgbClr val="00D084"/>
-                </a:solidFill>
-                <a:latin typeface="Segoe UI"/>
-              </a:rPr>
-              <a:t>▌ Controles Operativos</a:t>
+              <a:t>  ▸ Nombres oficiales del API en tooltip/leyenda del XLSX</a:t>
             </a:r>
           </a:p>
           <a:p>
@@ -6342,23 +7283,7 @@
                 </a:solidFill>
                 <a:latin typeface="Segoe UI"/>
               </a:rPr>
-              <a:t>  ▸ CORS: github.io + localhost</a:t>
-            </a:r>
-          </a:p>
-          <a:p>
-            <a:pPr>
-              <a:spcBef>
-                <a:spcPts val="500"/>
-              </a:spcBef>
-            </a:pPr>
-            <a:r>
-              <a:rPr sz="1400" b="0">
-                <a:solidFill>
-                  <a:srgbClr val="F0F4F8"/>
-                </a:solidFill>
-                <a:latin typeface="Segoe UI"/>
-              </a:rPr>
-              <a:t>  ▸ Rate limit: 60 req/min por IP</a:t>
+              <a:t>  ▸ 129 y 40 no son venta directa: son respaldo/traslado</a:t>
             </a:r>
           </a:p>
         </p:txBody>
@@ -6548,7 +7473,7 @@
                 </a:solidFill>
                 <a:latin typeface="Segoe UI"/>
               </a:rPr>
-              <a:t>Despliegue y Operación</a:t>
+              <a:t>Reportes XLSX</a:t>
             </a:r>
           </a:p>
         </p:txBody>
@@ -6675,7 +7600,7 @@
                 </a:solidFill>
                 <a:latin typeface="Segoe UI"/>
               </a:rPr>
-              <a:t>▌ Infraestructura</a:t>
+              <a:t>▌ Perfiles</a:t>
             </a:r>
           </a:p>
           <a:p>
@@ -6691,7 +7616,7 @@
                 </a:solidFill>
                 <a:latin typeface="Segoe UI"/>
               </a:rPr>
-              <a:t>  ▸ Frontend: GitHub Pages (auto-deploy desde main)</a:t>
+              <a:t>  ▸ Rápido: catálogo vigente + Disponible VES</a:t>
             </a:r>
           </a:p>
           <a:p>
@@ -6707,7 +7632,7 @@
                 </a:solidFill>
                 <a:latin typeface="Segoe UI"/>
               </a:rPr>
-              <a:t>  ▸ Backend: Render (gratuito, keep-alive cada 5 min)</a:t>
+              <a:t>  ▸ Completo: 129, 92, 40, 121, 122 + predespacho + revisión</a:t>
             </a:r>
           </a:p>
           <a:p/>
@@ -6724,7 +7649,7 @@
                 </a:solidFill>
                 <a:latin typeface="Segoe UI"/>
               </a:rPr>
-              <a:t>▌ Desarrollo Local</a:t>
+              <a:t>▌ Opciones avanzadas</a:t>
             </a:r>
           </a:p>
           <a:p>
@@ -6740,7 +7665,7 @@
                 </a:solidFill>
                 <a:latin typeface="Segoe UI"/>
               </a:rPr>
-              <a:t>  ▸ Frontend: npm run dev (localhost:3000)</a:t>
+              <a:t>  ▸ Alcance por línea, incluir no vigentes</a:t>
             </a:r>
           </a:p>
           <a:p>
@@ -6756,7 +7681,7 @@
                 </a:solidFill>
                 <a:latin typeface="Segoe UI"/>
               </a:rPr>
-              <a:t>  ▸ Backend: uvicorn app.main:app --reload</a:t>
+              <a:t>  ▸ Hojas Sin Catálogo y 122 (a pedido)</a:t>
             </a:r>
           </a:p>
           <a:p/>
@@ -6773,7 +7698,7 @@
                 </a:solidFill>
                 <a:latin typeface="Segoe UI"/>
               </a:rPr>
-              <a:t>▌ Ventana Operativa</a:t>
+              <a:t>▌ Exportaciones</a:t>
             </a:r>
           </a:p>
           <a:p>
@@ -6789,7 +7714,7 @@
                 </a:solidFill>
                 <a:latin typeface="Segoe UI"/>
               </a:rPr>
-              <a:t>  ▸ Lun-Sáb 07:00-22:59 hora Lima</a:t>
+              <a:t>  ▸ Estado: Con/Bajo/Sin, Sin Catálogo y 122</a:t>
             </a:r>
           </a:p>
           <a:p>
@@ -6805,7 +7730,23 @@
                 </a:solidFill>
                 <a:latin typeface="Segoe UI"/>
               </a:rPr>
-              <a:t>  ▸ Dom/madrugada: datos estáticos del último ciclo</a:t>
+              <a:t>  ▸ Alertas: Todos/Bajo/Sin</a:t>
+            </a:r>
+          </a:p>
+          <a:p>
+            <a:pPr>
+              <a:spcBef>
+                <a:spcPts val="500"/>
+              </a:spcBef>
+            </a:pPr>
+            <a:r>
+              <a:rPr sz="1400" b="0">
+                <a:solidFill>
+                  <a:srgbClr val="F0F4F8"/>
+                </a:solidFill>
+                <a:latin typeface="Segoe UI"/>
+              </a:rPr>
+              <a:t>  ▸ Nombres con perfil: ..._Rapido_ / ..._Completo_</a:t>
             </a:r>
           </a:p>
         </p:txBody>
@@ -6995,7 +7936,7 @@
                 </a:solidFill>
                 <a:latin typeface="Segoe UI"/>
               </a:rPr>
-              <a:t>Troubleshooting Común</a:t>
+              <a:t>Seguridad y Acceso</a:t>
             </a:r>
           </a:p>
         </p:txBody>
@@ -7122,7 +8063,7 @@
                 </a:solidFill>
                 <a:latin typeface="Segoe UI"/>
               </a:rPr>
-              <a:t>▌ Cache Stale</a:t>
+              <a:t>▌ Acceso (simulado)</a:t>
             </a:r>
           </a:p>
           <a:p>
@@ -7138,7 +8079,7 @@
                 </a:solidFill>
                 <a:latin typeface="Segoe UI"/>
               </a:rPr>
-              <a:t>  ▸ Síntoma: datos no se actualizan</a:t>
+              <a:t>  ▸ Login local: nombre + correo @cipsa.com.pe</a:t>
             </a:r>
           </a:p>
           <a:p>
@@ -7154,7 +8095,23 @@
                 </a:solidFill>
                 <a:latin typeface="Segoe UI"/>
               </a:rPr>
-              <a:t>  ▸ Solución: Forzar refresh o limpiar localStorage</a:t>
+              <a:t>  ▸ Sesión en localStorage; logout desde el header</a:t>
+            </a:r>
+          </a:p>
+          <a:p>
+            <a:pPr>
+              <a:spcBef>
+                <a:spcPts val="500"/>
+              </a:spcBef>
+            </a:pPr>
+            <a:r>
+              <a:rPr sz="1400" b="0">
+                <a:solidFill>
+                  <a:srgbClr val="F0F4F8"/>
+                </a:solidFill>
+                <a:latin typeface="Segoe UI"/>
+              </a:rPr>
+              <a:t>  ▸ No es autenticación real: firma los reportes</a:t>
             </a:r>
           </a:p>
           <a:p/>
@@ -7171,7 +8128,7 @@
                 </a:solidFill>
                 <a:latin typeface="Segoe UI"/>
               </a:rPr>
-              <a:t>▌ Categoría OTROS</a:t>
+              <a:t>▌ API</a:t>
             </a:r>
           </a:p>
           <a:p>
@@ -7187,7 +8144,7 @@
                 </a:solidFill>
                 <a:latin typeface="Segoe UI"/>
               </a:rPr>
-              <a:t>  ▸ Causa: código de línea no mapeado</a:t>
+              <a:t>  ▸ Clave de lectura para la PWA; admin separada</a:t>
             </a:r>
           </a:p>
           <a:p>
@@ -7203,7 +8160,7 @@
                 </a:solidFill>
                 <a:latin typeface="Segoe UI"/>
               </a:rPr>
-              <a:t>  ▸ Solución: Agregar a CATEGORIAS en constants.py</a:t>
+              <a:t>  ▸ CORS restringido y rate limit</a:t>
             </a:r>
           </a:p>
           <a:p/>
@@ -7220,7 +8177,7 @@
                 </a:solidFill>
                 <a:latin typeface="Segoe UI"/>
               </a:rPr>
-              <a:t>▌ Disponible 0 con existencias</a:t>
+              <a:t>▌ Datos</a:t>
             </a:r>
           </a:p>
           <a:p>
@@ -7236,7 +8193,7 @@
                 </a:solidFill>
                 <a:latin typeface="Segoe UI"/>
               </a:rPr>
-              <a:t>  ▸ Causa: stock solo en lotes no-VES (mktd, 121, 40, 129, 122)</a:t>
+              <a:t>  ▸ Cache local (7 días) y API en vivo</a:t>
             </a:r>
           </a:p>
           <a:p>
@@ -7252,7 +8209,7 @@
                 </a:solidFill>
                 <a:latin typeface="Segoe UI"/>
               </a:rPr>
-              <a:t>  ▸ Solución: ver chips por almacén en el buscador o columnas del XLSX</a:t>
+              <a:t>  ▸ Sin credenciales administrativas en el frontend</a:t>
             </a:r>
           </a:p>
         </p:txBody>

</xml_diff>